<commit_message>
updates in various files
</commit_message>
<xml_diff>
--- a/presentation_6_march_2026.pptx
+++ b/presentation_6_march_2026.pptx
@@ -14,7 +14,9 @@
     <p:sldId id="263" r:id="rId8"/>
     <p:sldId id="265" r:id="rId9"/>
     <p:sldId id="258" r:id="rId10"/>
-    <p:sldId id="264" r:id="rId11"/>
+    <p:sldId id="266" r:id="rId11"/>
+    <p:sldId id="267" r:id="rId12"/>
+    <p:sldId id="264" r:id="rId13"/>
   </p:sldIdLst>
   <p:sldSz cx="12192000" cy="6858000"/>
   <p:notesSz cx="6858000" cy="9144000"/>
@@ -268,7 +270,7 @@
           <a:p>
             <a:fld id="{84A31011-0B8E-40B0-B333-E081CF3EF4C8}" type="datetimeFigureOut">
               <a:rPr lang="en-US" smtClean="0"/>
-              <a:t>3/3/2026</a:t>
+              <a:t>3/4/2026</a:t>
             </a:fld>
             <a:endParaRPr lang="en-US"/>
           </a:p>
@@ -466,7 +468,7 @@
           <a:p>
             <a:fld id="{84A31011-0B8E-40B0-B333-E081CF3EF4C8}" type="datetimeFigureOut">
               <a:rPr lang="en-US" smtClean="0"/>
-              <a:t>3/3/2026</a:t>
+              <a:t>3/4/2026</a:t>
             </a:fld>
             <a:endParaRPr lang="en-US"/>
           </a:p>
@@ -674,7 +676,7 @@
           <a:p>
             <a:fld id="{84A31011-0B8E-40B0-B333-E081CF3EF4C8}" type="datetimeFigureOut">
               <a:rPr lang="en-US" smtClean="0"/>
-              <a:t>3/3/2026</a:t>
+              <a:t>3/4/2026</a:t>
             </a:fld>
             <a:endParaRPr lang="en-US"/>
           </a:p>
@@ -872,7 +874,7 @@
           <a:p>
             <a:fld id="{84A31011-0B8E-40B0-B333-E081CF3EF4C8}" type="datetimeFigureOut">
               <a:rPr lang="en-US" smtClean="0"/>
-              <a:t>3/3/2026</a:t>
+              <a:t>3/4/2026</a:t>
             </a:fld>
             <a:endParaRPr lang="en-US"/>
           </a:p>
@@ -1147,7 +1149,7 @@
           <a:p>
             <a:fld id="{84A31011-0B8E-40B0-B333-E081CF3EF4C8}" type="datetimeFigureOut">
               <a:rPr lang="en-US" smtClean="0"/>
-              <a:t>3/3/2026</a:t>
+              <a:t>3/4/2026</a:t>
             </a:fld>
             <a:endParaRPr lang="en-US"/>
           </a:p>
@@ -1412,7 +1414,7 @@
           <a:p>
             <a:fld id="{84A31011-0B8E-40B0-B333-E081CF3EF4C8}" type="datetimeFigureOut">
               <a:rPr lang="en-US" smtClean="0"/>
-              <a:t>3/3/2026</a:t>
+              <a:t>3/4/2026</a:t>
             </a:fld>
             <a:endParaRPr lang="en-US"/>
           </a:p>
@@ -1824,7 +1826,7 @@
           <a:p>
             <a:fld id="{84A31011-0B8E-40B0-B333-E081CF3EF4C8}" type="datetimeFigureOut">
               <a:rPr lang="en-US" smtClean="0"/>
-              <a:t>3/3/2026</a:t>
+              <a:t>3/4/2026</a:t>
             </a:fld>
             <a:endParaRPr lang="en-US"/>
           </a:p>
@@ -1965,7 +1967,7 @@
           <a:p>
             <a:fld id="{84A31011-0B8E-40B0-B333-E081CF3EF4C8}" type="datetimeFigureOut">
               <a:rPr lang="en-US" smtClean="0"/>
-              <a:t>3/3/2026</a:t>
+              <a:t>3/4/2026</a:t>
             </a:fld>
             <a:endParaRPr lang="en-US"/>
           </a:p>
@@ -2078,7 +2080,7 @@
           <a:p>
             <a:fld id="{84A31011-0B8E-40B0-B333-E081CF3EF4C8}" type="datetimeFigureOut">
               <a:rPr lang="en-US" smtClean="0"/>
-              <a:t>3/3/2026</a:t>
+              <a:t>3/4/2026</a:t>
             </a:fld>
             <a:endParaRPr lang="en-US"/>
           </a:p>
@@ -2389,7 +2391,7 @@
           <a:p>
             <a:fld id="{84A31011-0B8E-40B0-B333-E081CF3EF4C8}" type="datetimeFigureOut">
               <a:rPr lang="en-US" smtClean="0"/>
-              <a:t>3/3/2026</a:t>
+              <a:t>3/4/2026</a:t>
             </a:fld>
             <a:endParaRPr lang="en-US"/>
           </a:p>
@@ -2677,7 +2679,7 @@
           <a:p>
             <a:fld id="{84A31011-0B8E-40B0-B333-E081CF3EF4C8}" type="datetimeFigureOut">
               <a:rPr lang="en-US" smtClean="0"/>
-              <a:t>3/3/2026</a:t>
+              <a:t>3/4/2026</a:t>
             </a:fld>
             <a:endParaRPr lang="en-US"/>
           </a:p>
@@ -2918,7 +2920,7 @@
           <a:p>
             <a:fld id="{84A31011-0B8E-40B0-B333-E081CF3EF4C8}" type="datetimeFigureOut">
               <a:rPr lang="en-US" smtClean="0"/>
-              <a:t>3/3/2026</a:t>
+              <a:t>3/4/2026</a:t>
             </a:fld>
             <a:endParaRPr lang="en-US"/>
           </a:p>
@@ -3488,6 +3490,285 @@
           <p:cNvPr id="2" name="Title 1">
             <a:extLst>
               <a:ext uri="{FF2B5EF4-FFF2-40B4-BE49-F238E27FC236}">
+                <a16:creationId xmlns:a16="http://schemas.microsoft.com/office/drawing/2014/main" id="{AD1A0082-21C1-0110-05F4-DE8CE2667B6F}"/>
+              </a:ext>
+            </a:extLst>
+          </p:cNvPr>
+          <p:cNvSpPr>
+            <a:spLocks noGrp="1"/>
+          </p:cNvSpPr>
+          <p:nvPr>
+            <p:ph type="title"/>
+          </p:nvPr>
+        </p:nvSpPr>
+        <p:spPr/>
+        <p:txBody>
+          <a:bodyPr/>
+          <a:lstStyle/>
+          <a:p>
+            <a:r>
+              <a:rPr lang="en-US" dirty="0"/>
+              <a:t>Features</a:t>
+            </a:r>
+          </a:p>
+        </p:txBody>
+      </p:sp>
+      <p:sp>
+        <p:nvSpPr>
+          <p:cNvPr id="3" name="Content Placeholder 2">
+            <a:extLst>
+              <a:ext uri="{FF2B5EF4-FFF2-40B4-BE49-F238E27FC236}">
+                <a16:creationId xmlns:a16="http://schemas.microsoft.com/office/drawing/2014/main" id="{88733D94-AC51-42FE-AEB1-5C1C4CEB69A1}"/>
+              </a:ext>
+            </a:extLst>
+          </p:cNvPr>
+          <p:cNvSpPr>
+            <a:spLocks noGrp="1"/>
+          </p:cNvSpPr>
+          <p:nvPr>
+            <p:ph idx="1"/>
+          </p:nvPr>
+        </p:nvSpPr>
+        <p:spPr/>
+        <p:txBody>
+          <a:bodyPr/>
+          <a:lstStyle/>
+          <a:p>
+            <a:r>
+              <a:rPr lang="en-US" dirty="0"/>
+              <a:t>The BHSA is annotated with many features, e.g.</a:t>
+            </a:r>
+          </a:p>
+          <a:p>
+            <a:endParaRPr lang="en-US" dirty="0"/>
+          </a:p>
+          <a:p>
+            <a:r>
+              <a:rPr lang="en-US" dirty="0"/>
+              <a:t>Word level features:</a:t>
+            </a:r>
+          </a:p>
+          <a:p>
+            <a:r>
+              <a:rPr lang="en-US" dirty="0"/>
+              <a:t>Lexeme</a:t>
+            </a:r>
+          </a:p>
+          <a:p>
+            <a:r>
+              <a:rPr lang="en-US" dirty="0"/>
+              <a:t>Person/number/gender</a:t>
+            </a:r>
+          </a:p>
+          <a:p>
+            <a:r>
+              <a:rPr lang="en-US" dirty="0"/>
+              <a:t>Verbal stem/verbal tense</a:t>
+            </a:r>
+          </a:p>
+          <a:p>
+            <a:endParaRPr lang="en-US" dirty="0"/>
+          </a:p>
+          <a:p>
+            <a:r>
+              <a:rPr lang="en-US" dirty="0"/>
+              <a:t>Syntactic features</a:t>
+            </a:r>
+          </a:p>
+          <a:p>
+            <a:endParaRPr lang="en-US" dirty="0"/>
+          </a:p>
+        </p:txBody>
+      </p:sp>
+    </p:spTree>
+    <p:extLst>
+      <p:ext uri="{BB962C8B-B14F-4D97-AF65-F5344CB8AC3E}">
+        <p14:creationId xmlns:p14="http://schemas.microsoft.com/office/powerpoint/2010/main" val="3462862467"/>
+      </p:ext>
+    </p:extLst>
+  </p:cSld>
+  <p:clrMapOvr>
+    <a:masterClrMapping/>
+  </p:clrMapOvr>
+</p:sld>
+</file>
+
+<file path=ppt/slides/slide11.xml><?xml version="1.0" encoding="utf-8"?>
+<p:sld xmlns:a="http://schemas.openxmlformats.org/drawingml/2006/main" xmlns:r="http://schemas.openxmlformats.org/officeDocument/2006/relationships" xmlns:p="http://schemas.openxmlformats.org/presentationml/2006/main">
+  <p:cSld>
+    <p:spTree>
+      <p:nvGrpSpPr>
+        <p:cNvPr id="1" name=""/>
+        <p:cNvGrpSpPr/>
+        <p:nvPr/>
+      </p:nvGrpSpPr>
+      <p:grpSpPr>
+        <a:xfrm>
+          <a:off x="0" y="0"/>
+          <a:ext cx="0" cy="0"/>
+          <a:chOff x="0" y="0"/>
+          <a:chExt cx="0" cy="0"/>
+        </a:xfrm>
+      </p:grpSpPr>
+      <p:sp>
+        <p:nvSpPr>
+          <p:cNvPr id="2" name="Title 1">
+            <a:extLst>
+              <a:ext uri="{FF2B5EF4-FFF2-40B4-BE49-F238E27FC236}">
+                <a16:creationId xmlns:a16="http://schemas.microsoft.com/office/drawing/2014/main" id="{0FC6F630-E6E0-4AC6-51E5-FD6E329C2CB8}"/>
+              </a:ext>
+            </a:extLst>
+          </p:cNvPr>
+          <p:cNvSpPr>
+            <a:spLocks noGrp="1"/>
+          </p:cNvSpPr>
+          <p:nvPr>
+            <p:ph type="title"/>
+          </p:nvPr>
+        </p:nvSpPr>
+        <p:spPr/>
+        <p:txBody>
+          <a:bodyPr/>
+          <a:lstStyle/>
+          <a:p>
+            <a:r>
+              <a:rPr lang="en-US" dirty="0"/>
+              <a:t>Queries</a:t>
+            </a:r>
+          </a:p>
+        </p:txBody>
+      </p:sp>
+      <p:sp>
+        <p:nvSpPr>
+          <p:cNvPr id="3" name="Content Placeholder 2">
+            <a:extLst>
+              <a:ext uri="{FF2B5EF4-FFF2-40B4-BE49-F238E27FC236}">
+                <a16:creationId xmlns:a16="http://schemas.microsoft.com/office/drawing/2014/main" id="{D9C94CD4-7691-12E7-48B7-0EEF24706D5F}"/>
+              </a:ext>
+            </a:extLst>
+          </p:cNvPr>
+          <p:cNvSpPr>
+            <a:spLocks noGrp="1"/>
+          </p:cNvSpPr>
+          <p:nvPr>
+            <p:ph idx="1"/>
+          </p:nvPr>
+        </p:nvSpPr>
+        <p:spPr/>
+        <p:txBody>
+          <a:bodyPr>
+            <a:normAutofit fontScale="92500" lnSpcReduction="20000"/>
+          </a:bodyPr>
+          <a:lstStyle/>
+          <a:p>
+            <a:pPr marL="0" indent="0">
+              <a:buNone/>
+            </a:pPr>
+            <a:r>
+              <a:rPr lang="en-US" dirty="0"/>
+              <a:t>A query has a template structure:</a:t>
+            </a:r>
+          </a:p>
+          <a:p>
+            <a:endParaRPr lang="en-US" dirty="0"/>
+          </a:p>
+          <a:p>
+            <a:pPr marL="0" indent="0">
+              <a:buNone/>
+            </a:pPr>
+            <a:r>
+              <a:rPr lang="en-US" dirty="0"/>
+              <a:t>object-type feature=value</a:t>
+            </a:r>
+          </a:p>
+          <a:p>
+            <a:pPr marL="0" indent="0">
+              <a:buNone/>
+            </a:pPr>
+            <a:endParaRPr lang="en-US"/>
+          </a:p>
+          <a:p>
+            <a:pPr marL="0" indent="0">
+              <a:buNone/>
+            </a:pPr>
+            <a:endParaRPr lang="en-US" dirty="0"/>
+          </a:p>
+          <a:p>
+            <a:pPr marL="0" indent="0">
+              <a:buNone/>
+            </a:pPr>
+            <a:r>
+              <a:rPr lang="en-US" dirty="0"/>
+              <a:t>Examples:</a:t>
+            </a:r>
+          </a:p>
+          <a:p>
+            <a:pPr marL="0" indent="0">
+              <a:buNone/>
+            </a:pPr>
+            <a:endParaRPr lang="en-US" dirty="0"/>
+          </a:p>
+          <a:p>
+            <a:pPr marL="0" indent="0">
+              <a:buNone/>
+            </a:pPr>
+            <a:r>
+              <a:rPr lang="en-US" dirty="0"/>
+              <a:t>word nu=pl</a:t>
+            </a:r>
+          </a:p>
+          <a:p>
+            <a:pPr marL="0" indent="0">
+              <a:buNone/>
+            </a:pPr>
+            <a:endParaRPr lang="en-US" dirty="0"/>
+          </a:p>
+          <a:p>
+            <a:pPr marL="0" indent="0">
+              <a:buNone/>
+            </a:pPr>
+            <a:r>
+              <a:rPr lang="en-US" dirty="0"/>
+              <a:t>phrase function=Subj</a:t>
+            </a:r>
+          </a:p>
+        </p:txBody>
+      </p:sp>
+    </p:spTree>
+    <p:extLst>
+      <p:ext uri="{BB962C8B-B14F-4D97-AF65-F5344CB8AC3E}">
+        <p14:creationId xmlns:p14="http://schemas.microsoft.com/office/powerpoint/2010/main" val="3237721129"/>
+      </p:ext>
+    </p:extLst>
+  </p:cSld>
+  <p:clrMapOvr>
+    <a:masterClrMapping/>
+  </p:clrMapOvr>
+</p:sld>
+</file>
+
+<file path=ppt/slides/slide12.xml><?xml version="1.0" encoding="utf-8"?>
+<p:sld xmlns:a="http://schemas.openxmlformats.org/drawingml/2006/main" xmlns:r="http://schemas.openxmlformats.org/officeDocument/2006/relationships" xmlns:p="http://schemas.openxmlformats.org/presentationml/2006/main">
+  <p:cSld>
+    <p:spTree>
+      <p:nvGrpSpPr>
+        <p:cNvPr id="1" name=""/>
+        <p:cNvGrpSpPr/>
+        <p:nvPr/>
+      </p:nvGrpSpPr>
+      <p:grpSpPr>
+        <a:xfrm>
+          <a:off x="0" y="0"/>
+          <a:ext cx="0" cy="0"/>
+          <a:chOff x="0" y="0"/>
+          <a:chExt cx="0" cy="0"/>
+        </a:xfrm>
+      </p:grpSpPr>
+      <p:sp>
+        <p:nvSpPr>
+          <p:cNvPr id="2" name="Title 1">
+            <a:extLst>
+              <a:ext uri="{FF2B5EF4-FFF2-40B4-BE49-F238E27FC236}">
                 <a16:creationId xmlns:a16="http://schemas.microsoft.com/office/drawing/2014/main" id="{7E006509-2926-79AE-4A53-B7B8FC8077B8}"/>
               </a:ext>
             </a:extLst>
@@ -3504,7 +3785,10 @@
           <a:bodyPr/>
           <a:lstStyle/>
           <a:p>
-            <a:endParaRPr lang="en-US"/>
+            <a:r>
+              <a:rPr lang="en-US" dirty="0"/>
+              <a:t>Time to make queries!</a:t>
+            </a:r>
           </a:p>
         </p:txBody>
       </p:sp>
@@ -3719,10 +4003,10 @@
           <a:bodyPr/>
           <a:lstStyle/>
           <a:p>
-            <a:r>
-              <a:rPr lang="en-US" dirty="0"/>
-              <a:t>Goals:</a:t>
-            </a:r>
+            <a:pPr marL="0" indent="0">
+              <a:buNone/>
+            </a:pPr>
+            <a:endParaRPr lang="en-US" dirty="0"/>
           </a:p>
           <a:p>
             <a:endParaRPr lang="en-US" dirty="0"/>
@@ -3844,6 +4128,9 @@
           <a:bodyPr/>
           <a:lstStyle/>
           <a:p>
+            <a:pPr marL="0" indent="0">
+              <a:buNone/>
+            </a:pPr>
             <a:r>
               <a:rPr lang="en-US" dirty="0"/>
               <a:t>3 afternoons</a:t>
@@ -3858,7 +4145,7 @@
             </a:pPr>
             <a:r>
               <a:rPr lang="en-US" dirty="0"/>
-              <a:t>1. Introduction, word level queries.</a:t>
+              <a:t>1. Introduction, word level queries in TF Browser.</a:t>
             </a:r>
           </a:p>
           <a:p>
@@ -3867,7 +4154,15 @@
             </a:pPr>
             <a:r>
               <a:rPr lang="en-US" dirty="0"/>
-              <a:t>2. Syntactic queries, .</a:t>
+              <a:t>2. Syntactic queries, queries in </a:t>
+            </a:r>
+            <a:r>
+              <a:rPr lang="en-US" dirty="0" err="1"/>
+              <a:t>Jupyter</a:t>
+            </a:r>
+            <a:r>
+              <a:rPr lang="en-US" dirty="0"/>
+              <a:t> Notebook.</a:t>
             </a:r>
           </a:p>
           <a:p>
@@ -4061,6 +4356,9 @@
           <a:bodyPr/>
           <a:lstStyle/>
           <a:p>
+            <a:pPr marL="0" indent="0">
+              <a:buNone/>
+            </a:pPr>
             <a:r>
               <a:rPr lang="en-US" dirty="0"/>
               <a:t>Or: Text-Fabric vs Accordance</a:t>
@@ -4070,6 +4368,9 @@
             <a:endParaRPr lang="en-US" dirty="0"/>
           </a:p>
           <a:p>
+            <a:pPr marL="0" indent="0">
+              <a:buNone/>
+            </a:pPr>
             <a:r>
               <a:rPr lang="en-US" dirty="0"/>
               <a:t>Pros of open source</a:t>
@@ -4088,6 +4389,9 @@
             <a:endParaRPr lang="en-US" dirty="0"/>
           </a:p>
           <a:p>
+            <a:pPr marL="0" indent="0">
+              <a:buNone/>
+            </a:pPr>
             <a:r>
               <a:rPr lang="en-US" dirty="0"/>
               <a:t>Pros of closed source</a:t>

</xml_diff>

<commit_message>
changes in various files
</commit_message>
<xml_diff>
--- a/presentation_6_march_2026.pptx
+++ b/presentation_6_march_2026.pptx
@@ -6,17 +6,16 @@
   </p:sldMasterIdLst>
   <p:sldIdLst>
     <p:sldId id="256" r:id="rId2"/>
-    <p:sldId id="257" r:id="rId3"/>
-    <p:sldId id="262" r:id="rId4"/>
-    <p:sldId id="259" r:id="rId5"/>
-    <p:sldId id="261" r:id="rId6"/>
-    <p:sldId id="260" r:id="rId7"/>
-    <p:sldId id="263" r:id="rId8"/>
-    <p:sldId id="265" r:id="rId9"/>
+    <p:sldId id="262" r:id="rId3"/>
+    <p:sldId id="259" r:id="rId4"/>
+    <p:sldId id="261" r:id="rId5"/>
+    <p:sldId id="260" r:id="rId6"/>
+    <p:sldId id="263" r:id="rId7"/>
+    <p:sldId id="265" r:id="rId8"/>
+    <p:sldId id="267" r:id="rId9"/>
     <p:sldId id="258" r:id="rId10"/>
     <p:sldId id="266" r:id="rId11"/>
-    <p:sldId id="267" r:id="rId12"/>
-    <p:sldId id="264" r:id="rId13"/>
+    <p:sldId id="264" r:id="rId12"/>
   </p:sldIdLst>
   <p:sldSz cx="12192000" cy="6858000"/>
   <p:notesSz cx="6858000" cy="9144000"/>
@@ -270,7 +269,7 @@
           <a:p>
             <a:fld id="{84A31011-0B8E-40B0-B333-E081CF3EF4C8}" type="datetimeFigureOut">
               <a:rPr lang="en-US" smtClean="0"/>
-              <a:t>3/4/2026</a:t>
+              <a:t>3/5/2026</a:t>
             </a:fld>
             <a:endParaRPr lang="en-US"/>
           </a:p>
@@ -468,7 +467,7 @@
           <a:p>
             <a:fld id="{84A31011-0B8E-40B0-B333-E081CF3EF4C8}" type="datetimeFigureOut">
               <a:rPr lang="en-US" smtClean="0"/>
-              <a:t>3/4/2026</a:t>
+              <a:t>3/5/2026</a:t>
             </a:fld>
             <a:endParaRPr lang="en-US"/>
           </a:p>
@@ -676,7 +675,7 @@
           <a:p>
             <a:fld id="{84A31011-0B8E-40B0-B333-E081CF3EF4C8}" type="datetimeFigureOut">
               <a:rPr lang="en-US" smtClean="0"/>
-              <a:t>3/4/2026</a:t>
+              <a:t>3/5/2026</a:t>
             </a:fld>
             <a:endParaRPr lang="en-US"/>
           </a:p>
@@ -874,7 +873,7 @@
           <a:p>
             <a:fld id="{84A31011-0B8E-40B0-B333-E081CF3EF4C8}" type="datetimeFigureOut">
               <a:rPr lang="en-US" smtClean="0"/>
-              <a:t>3/4/2026</a:t>
+              <a:t>3/5/2026</a:t>
             </a:fld>
             <a:endParaRPr lang="en-US"/>
           </a:p>
@@ -1149,7 +1148,7 @@
           <a:p>
             <a:fld id="{84A31011-0B8E-40B0-B333-E081CF3EF4C8}" type="datetimeFigureOut">
               <a:rPr lang="en-US" smtClean="0"/>
-              <a:t>3/4/2026</a:t>
+              <a:t>3/5/2026</a:t>
             </a:fld>
             <a:endParaRPr lang="en-US"/>
           </a:p>
@@ -1414,7 +1413,7 @@
           <a:p>
             <a:fld id="{84A31011-0B8E-40B0-B333-E081CF3EF4C8}" type="datetimeFigureOut">
               <a:rPr lang="en-US" smtClean="0"/>
-              <a:t>3/4/2026</a:t>
+              <a:t>3/5/2026</a:t>
             </a:fld>
             <a:endParaRPr lang="en-US"/>
           </a:p>
@@ -1826,7 +1825,7 @@
           <a:p>
             <a:fld id="{84A31011-0B8E-40B0-B333-E081CF3EF4C8}" type="datetimeFigureOut">
               <a:rPr lang="en-US" smtClean="0"/>
-              <a:t>3/4/2026</a:t>
+              <a:t>3/5/2026</a:t>
             </a:fld>
             <a:endParaRPr lang="en-US"/>
           </a:p>
@@ -1967,7 +1966,7 @@
           <a:p>
             <a:fld id="{84A31011-0B8E-40B0-B333-E081CF3EF4C8}" type="datetimeFigureOut">
               <a:rPr lang="en-US" smtClean="0"/>
-              <a:t>3/4/2026</a:t>
+              <a:t>3/5/2026</a:t>
             </a:fld>
             <a:endParaRPr lang="en-US"/>
           </a:p>
@@ -2080,7 +2079,7 @@
           <a:p>
             <a:fld id="{84A31011-0B8E-40B0-B333-E081CF3EF4C8}" type="datetimeFigureOut">
               <a:rPr lang="en-US" smtClean="0"/>
-              <a:t>3/4/2026</a:t>
+              <a:t>3/5/2026</a:t>
             </a:fld>
             <a:endParaRPr lang="en-US"/>
           </a:p>
@@ -2391,7 +2390,7 @@
           <a:p>
             <a:fld id="{84A31011-0B8E-40B0-B333-E081CF3EF4C8}" type="datetimeFigureOut">
               <a:rPr lang="en-US" smtClean="0"/>
-              <a:t>3/4/2026</a:t>
+              <a:t>3/5/2026</a:t>
             </a:fld>
             <a:endParaRPr lang="en-US"/>
           </a:p>
@@ -2679,7 +2678,7 @@
           <a:p>
             <a:fld id="{84A31011-0B8E-40B0-B333-E081CF3EF4C8}" type="datetimeFigureOut">
               <a:rPr lang="en-US" smtClean="0"/>
-              <a:t>3/4/2026</a:t>
+              <a:t>3/5/2026</a:t>
             </a:fld>
             <a:endParaRPr lang="en-US"/>
           </a:p>
@@ -2920,7 +2919,7 @@
           <a:p>
             <a:fld id="{84A31011-0B8E-40B0-B333-E081CF3EF4C8}" type="datetimeFigureOut">
               <a:rPr lang="en-US" smtClean="0"/>
-              <a:t>3/4/2026</a:t>
+              <a:t>3/5/2026</a:t>
             </a:fld>
             <a:endParaRPr lang="en-US"/>
           </a:p>
@@ -3531,7 +3530,9 @@
         </p:nvSpPr>
         <p:spPr/>
         <p:txBody>
-          <a:bodyPr/>
+          <a:bodyPr>
+            <a:normAutofit lnSpcReduction="10000"/>
+          </a:bodyPr>
           <a:lstStyle/>
           <a:p>
             <a:r>
@@ -3549,18 +3550,27 @@
             </a:r>
           </a:p>
           <a:p>
+            <a:pPr marL="0" indent="0">
+              <a:buNone/>
+            </a:pPr>
             <a:r>
               <a:rPr lang="en-US" dirty="0"/>
               <a:t>Lexeme</a:t>
             </a:r>
           </a:p>
           <a:p>
+            <a:pPr marL="0" indent="0">
+              <a:buNone/>
+            </a:pPr>
             <a:r>
               <a:rPr lang="en-US" dirty="0"/>
               <a:t>Person/number/gender</a:t>
             </a:r>
           </a:p>
           <a:p>
+            <a:pPr marL="0" indent="0">
+              <a:buNone/>
+            </a:pPr>
             <a:r>
               <a:rPr lang="en-US" dirty="0"/>
               <a:t>Verbal stem/verbal tense</a:t>
@@ -3573,6 +3583,15 @@
             <a:r>
               <a:rPr lang="en-US" dirty="0"/>
               <a:t>Syntactic features</a:t>
+            </a:r>
+          </a:p>
+          <a:p>
+            <a:pPr marL="0" indent="0">
+              <a:buNone/>
+            </a:pPr>
+            <a:r>
+              <a:rPr lang="en-US" dirty="0"/>
+              <a:t>Phrase types/functions</a:t>
             </a:r>
           </a:p>
           <a:p>
@@ -3615,160 +3634,6 @@
           <p:cNvPr id="2" name="Title 1">
             <a:extLst>
               <a:ext uri="{FF2B5EF4-FFF2-40B4-BE49-F238E27FC236}">
-                <a16:creationId xmlns:a16="http://schemas.microsoft.com/office/drawing/2014/main" id="{0FC6F630-E6E0-4AC6-51E5-FD6E329C2CB8}"/>
-              </a:ext>
-            </a:extLst>
-          </p:cNvPr>
-          <p:cNvSpPr>
-            <a:spLocks noGrp="1"/>
-          </p:cNvSpPr>
-          <p:nvPr>
-            <p:ph type="title"/>
-          </p:nvPr>
-        </p:nvSpPr>
-        <p:spPr/>
-        <p:txBody>
-          <a:bodyPr/>
-          <a:lstStyle/>
-          <a:p>
-            <a:r>
-              <a:rPr lang="en-US" dirty="0"/>
-              <a:t>Queries</a:t>
-            </a:r>
-          </a:p>
-        </p:txBody>
-      </p:sp>
-      <p:sp>
-        <p:nvSpPr>
-          <p:cNvPr id="3" name="Content Placeholder 2">
-            <a:extLst>
-              <a:ext uri="{FF2B5EF4-FFF2-40B4-BE49-F238E27FC236}">
-                <a16:creationId xmlns:a16="http://schemas.microsoft.com/office/drawing/2014/main" id="{D9C94CD4-7691-12E7-48B7-0EEF24706D5F}"/>
-              </a:ext>
-            </a:extLst>
-          </p:cNvPr>
-          <p:cNvSpPr>
-            <a:spLocks noGrp="1"/>
-          </p:cNvSpPr>
-          <p:nvPr>
-            <p:ph idx="1"/>
-          </p:nvPr>
-        </p:nvSpPr>
-        <p:spPr/>
-        <p:txBody>
-          <a:bodyPr>
-            <a:normAutofit fontScale="92500" lnSpcReduction="20000"/>
-          </a:bodyPr>
-          <a:lstStyle/>
-          <a:p>
-            <a:pPr marL="0" indent="0">
-              <a:buNone/>
-            </a:pPr>
-            <a:r>
-              <a:rPr lang="en-US" dirty="0"/>
-              <a:t>A query has a template structure:</a:t>
-            </a:r>
-          </a:p>
-          <a:p>
-            <a:endParaRPr lang="en-US" dirty="0"/>
-          </a:p>
-          <a:p>
-            <a:pPr marL="0" indent="0">
-              <a:buNone/>
-            </a:pPr>
-            <a:r>
-              <a:rPr lang="en-US" dirty="0"/>
-              <a:t>object-type feature=value</a:t>
-            </a:r>
-          </a:p>
-          <a:p>
-            <a:pPr marL="0" indent="0">
-              <a:buNone/>
-            </a:pPr>
-            <a:endParaRPr lang="en-US"/>
-          </a:p>
-          <a:p>
-            <a:pPr marL="0" indent="0">
-              <a:buNone/>
-            </a:pPr>
-            <a:endParaRPr lang="en-US" dirty="0"/>
-          </a:p>
-          <a:p>
-            <a:pPr marL="0" indent="0">
-              <a:buNone/>
-            </a:pPr>
-            <a:r>
-              <a:rPr lang="en-US" dirty="0"/>
-              <a:t>Examples:</a:t>
-            </a:r>
-          </a:p>
-          <a:p>
-            <a:pPr marL="0" indent="0">
-              <a:buNone/>
-            </a:pPr>
-            <a:endParaRPr lang="en-US" dirty="0"/>
-          </a:p>
-          <a:p>
-            <a:pPr marL="0" indent="0">
-              <a:buNone/>
-            </a:pPr>
-            <a:r>
-              <a:rPr lang="en-US" dirty="0"/>
-              <a:t>word nu=pl</a:t>
-            </a:r>
-          </a:p>
-          <a:p>
-            <a:pPr marL="0" indent="0">
-              <a:buNone/>
-            </a:pPr>
-            <a:endParaRPr lang="en-US" dirty="0"/>
-          </a:p>
-          <a:p>
-            <a:pPr marL="0" indent="0">
-              <a:buNone/>
-            </a:pPr>
-            <a:r>
-              <a:rPr lang="en-US" dirty="0"/>
-              <a:t>phrase function=Subj</a:t>
-            </a:r>
-          </a:p>
-        </p:txBody>
-      </p:sp>
-    </p:spTree>
-    <p:extLst>
-      <p:ext uri="{BB962C8B-B14F-4D97-AF65-F5344CB8AC3E}">
-        <p14:creationId xmlns:p14="http://schemas.microsoft.com/office/powerpoint/2010/main" val="3237721129"/>
-      </p:ext>
-    </p:extLst>
-  </p:cSld>
-  <p:clrMapOvr>
-    <a:masterClrMapping/>
-  </p:clrMapOvr>
-</p:sld>
-</file>
-
-<file path=ppt/slides/slide12.xml><?xml version="1.0" encoding="utf-8"?>
-<p:sld xmlns:a="http://schemas.openxmlformats.org/drawingml/2006/main" xmlns:r="http://schemas.openxmlformats.org/officeDocument/2006/relationships" xmlns:p="http://schemas.openxmlformats.org/presentationml/2006/main">
-  <p:cSld>
-    <p:spTree>
-      <p:nvGrpSpPr>
-        <p:cNvPr id="1" name=""/>
-        <p:cNvGrpSpPr/>
-        <p:nvPr/>
-      </p:nvGrpSpPr>
-      <p:grpSpPr>
-        <a:xfrm>
-          <a:off x="0" y="0"/>
-          <a:ext cx="0" cy="0"/>
-          <a:chOff x="0" y="0"/>
-          <a:chExt cx="0" cy="0"/>
-        </a:xfrm>
-      </p:grpSpPr>
-      <p:sp>
-        <p:nvSpPr>
-          <p:cNvPr id="2" name="Title 1">
-            <a:extLst>
-              <a:ext uri="{FF2B5EF4-FFF2-40B4-BE49-F238E27FC236}">
                 <a16:creationId xmlns:a16="http://schemas.microsoft.com/office/drawing/2014/main" id="{7E006509-2926-79AE-4A53-B7B8FC8077B8}"/>
               </a:ext>
             </a:extLst>
@@ -3852,7 +3717,7 @@
           <p:cNvPr id="2" name="Title 1">
             <a:extLst>
               <a:ext uri="{FF2B5EF4-FFF2-40B4-BE49-F238E27FC236}">
-                <a16:creationId xmlns:a16="http://schemas.microsoft.com/office/drawing/2014/main" id="{68CEEC44-095D-6CE1-927B-8B3BCC88C34F}"/>
+                <a16:creationId xmlns:a16="http://schemas.microsoft.com/office/drawing/2014/main" id="{DD280ED4-CFC3-C7A5-ACC3-A3C0AA30F8F3}"/>
               </a:ext>
             </a:extLst>
           </p:cNvPr>
@@ -3870,7 +3735,7 @@
           <a:p>
             <a:r>
               <a:rPr lang="en-US" dirty="0"/>
-              <a:t>Overview</a:t>
+              <a:t>Goal</a:t>
             </a:r>
           </a:p>
         </p:txBody>
@@ -3880,7 +3745,7 @@
           <p:cNvPr id="3" name="Content Placeholder 2">
             <a:extLst>
               <a:ext uri="{FF2B5EF4-FFF2-40B4-BE49-F238E27FC236}">
-                <a16:creationId xmlns:a16="http://schemas.microsoft.com/office/drawing/2014/main" id="{9C30DF9C-B759-20A2-E33B-3A520F2B5F38}"/>
+                <a16:creationId xmlns:a16="http://schemas.microsoft.com/office/drawing/2014/main" id="{00959AC0-DE93-A978-4AE1-93DB1ABD47D4}"/>
               </a:ext>
             </a:extLst>
           </p:cNvPr>
@@ -3896,38 +3761,56 @@
           <a:bodyPr/>
           <a:lstStyle/>
           <a:p>
-            <a:r>
-              <a:rPr lang="en-US" dirty="0"/>
-              <a:t>Introduction</a:t>
-            </a:r>
-          </a:p>
-          <a:p>
-            <a:r>
-              <a:rPr lang="en-US" dirty="0"/>
-              <a:t>Plan</a:t>
-            </a:r>
-          </a:p>
-          <a:p>
-            <a:r>
-              <a:rPr lang="en-US" dirty="0"/>
-              <a:t>Open Source vs Closed Source</a:t>
-            </a:r>
-          </a:p>
-          <a:p>
-            <a:r>
-              <a:rPr lang="en-US" dirty="0"/>
-              <a:t>Queries in Search</a:t>
-            </a:r>
-          </a:p>
-          <a:p>
+            <a:pPr marL="0" indent="0">
+              <a:buNone/>
+            </a:pPr>
             <a:endParaRPr lang="en-US" dirty="0"/>
+          </a:p>
+          <a:p>
+            <a:endParaRPr lang="en-US" dirty="0"/>
+          </a:p>
+          <a:p>
+            <a:r>
+              <a:rPr lang="en-US" dirty="0"/>
+              <a:t>Make queries in </a:t>
+            </a:r>
+            <a:r>
+              <a:rPr lang="en-US" i="1" dirty="0"/>
+              <a:t>Biblia Hebraica </a:t>
+            </a:r>
+            <a:r>
+              <a:rPr lang="en-US" i="1" dirty="0" err="1"/>
+              <a:t>Stuttgartensia</a:t>
+            </a:r>
+            <a:r>
+              <a:rPr lang="en-US" i="1" dirty="0"/>
+              <a:t> </a:t>
+            </a:r>
+            <a:r>
+              <a:rPr lang="en-US" i="1" dirty="0" err="1"/>
+              <a:t>Amstelodamensis</a:t>
+            </a:r>
+            <a:r>
+              <a:rPr lang="en-US" i="1" dirty="0"/>
+              <a:t> </a:t>
+            </a:r>
+            <a:r>
+              <a:rPr lang="en-US" dirty="0"/>
+              <a:t>(BHSA).</a:t>
+            </a:r>
+          </a:p>
+          <a:p>
+            <a:r>
+              <a:rPr lang="en-US" dirty="0"/>
+              <a:t>Analyze the results.</a:t>
+            </a:r>
           </a:p>
         </p:txBody>
       </p:sp>
     </p:spTree>
     <p:extLst>
       <p:ext uri="{BB962C8B-B14F-4D97-AF65-F5344CB8AC3E}">
-        <p14:creationId xmlns:p14="http://schemas.microsoft.com/office/powerpoint/2010/main" val="1636396982"/>
+        <p14:creationId xmlns:p14="http://schemas.microsoft.com/office/powerpoint/2010/main" val="1257089728"/>
       </p:ext>
     </p:extLst>
   </p:cSld>
@@ -3959,131 +3842,6 @@
           <p:cNvPr id="2" name="Title 1">
             <a:extLst>
               <a:ext uri="{FF2B5EF4-FFF2-40B4-BE49-F238E27FC236}">
-                <a16:creationId xmlns:a16="http://schemas.microsoft.com/office/drawing/2014/main" id="{DD280ED4-CFC3-C7A5-ACC3-A3C0AA30F8F3}"/>
-              </a:ext>
-            </a:extLst>
-          </p:cNvPr>
-          <p:cNvSpPr>
-            <a:spLocks noGrp="1"/>
-          </p:cNvSpPr>
-          <p:nvPr>
-            <p:ph type="title"/>
-          </p:nvPr>
-        </p:nvSpPr>
-        <p:spPr/>
-        <p:txBody>
-          <a:bodyPr/>
-          <a:lstStyle/>
-          <a:p>
-            <a:r>
-              <a:rPr lang="en-US" dirty="0"/>
-              <a:t>Goals</a:t>
-            </a:r>
-          </a:p>
-        </p:txBody>
-      </p:sp>
-      <p:sp>
-        <p:nvSpPr>
-          <p:cNvPr id="3" name="Content Placeholder 2">
-            <a:extLst>
-              <a:ext uri="{FF2B5EF4-FFF2-40B4-BE49-F238E27FC236}">
-                <a16:creationId xmlns:a16="http://schemas.microsoft.com/office/drawing/2014/main" id="{00959AC0-DE93-A978-4AE1-93DB1ABD47D4}"/>
-              </a:ext>
-            </a:extLst>
-          </p:cNvPr>
-          <p:cNvSpPr>
-            <a:spLocks noGrp="1"/>
-          </p:cNvSpPr>
-          <p:nvPr>
-            <p:ph idx="1"/>
-          </p:nvPr>
-        </p:nvSpPr>
-        <p:spPr/>
-        <p:txBody>
-          <a:bodyPr/>
-          <a:lstStyle/>
-          <a:p>
-            <a:pPr marL="0" indent="0">
-              <a:buNone/>
-            </a:pPr>
-            <a:endParaRPr lang="en-US" dirty="0"/>
-          </a:p>
-          <a:p>
-            <a:endParaRPr lang="en-US" dirty="0"/>
-          </a:p>
-          <a:p>
-            <a:r>
-              <a:rPr lang="en-US" dirty="0"/>
-              <a:t>Make queries in </a:t>
-            </a:r>
-            <a:r>
-              <a:rPr lang="en-US" i="1" dirty="0"/>
-              <a:t>Biblia Hebraica </a:t>
-            </a:r>
-            <a:r>
-              <a:rPr lang="en-US" i="1" dirty="0" err="1"/>
-              <a:t>Stuttgartensia</a:t>
-            </a:r>
-            <a:r>
-              <a:rPr lang="en-US" i="1" dirty="0"/>
-              <a:t> </a:t>
-            </a:r>
-            <a:r>
-              <a:rPr lang="en-US" i="1" dirty="0" err="1"/>
-              <a:t>Amstelodamensis</a:t>
-            </a:r>
-            <a:r>
-              <a:rPr lang="en-US" i="1" dirty="0"/>
-              <a:t> </a:t>
-            </a:r>
-            <a:r>
-              <a:rPr lang="en-US" dirty="0"/>
-              <a:t>(BHSA).</a:t>
-            </a:r>
-          </a:p>
-          <a:p>
-            <a:r>
-              <a:rPr lang="en-US" dirty="0"/>
-              <a:t>Analyze the results.</a:t>
-            </a:r>
-          </a:p>
-        </p:txBody>
-      </p:sp>
-    </p:spTree>
-    <p:extLst>
-      <p:ext uri="{BB962C8B-B14F-4D97-AF65-F5344CB8AC3E}">
-        <p14:creationId xmlns:p14="http://schemas.microsoft.com/office/powerpoint/2010/main" val="1257089728"/>
-      </p:ext>
-    </p:extLst>
-  </p:cSld>
-  <p:clrMapOvr>
-    <a:masterClrMapping/>
-  </p:clrMapOvr>
-</p:sld>
-</file>
-
-<file path=ppt/slides/slide4.xml><?xml version="1.0" encoding="utf-8"?>
-<p:sld xmlns:a="http://schemas.openxmlformats.org/drawingml/2006/main" xmlns:r="http://schemas.openxmlformats.org/officeDocument/2006/relationships" xmlns:p="http://schemas.openxmlformats.org/presentationml/2006/main">
-  <p:cSld>
-    <p:spTree>
-      <p:nvGrpSpPr>
-        <p:cNvPr id="1" name=""/>
-        <p:cNvGrpSpPr/>
-        <p:nvPr/>
-      </p:nvGrpSpPr>
-      <p:grpSpPr>
-        <a:xfrm>
-          <a:off x="0" y="0"/>
-          <a:ext cx="0" cy="0"/>
-          <a:chOff x="0" y="0"/>
-          <a:chExt cx="0" cy="0"/>
-        </a:xfrm>
-      </p:grpSpPr>
-      <p:sp>
-        <p:nvSpPr>
-          <p:cNvPr id="2" name="Title 1">
-            <a:extLst>
-              <a:ext uri="{FF2B5EF4-FFF2-40B4-BE49-F238E27FC236}">
                 <a16:creationId xmlns:a16="http://schemas.microsoft.com/office/drawing/2014/main" id="{6A7FFE8C-3E35-8F94-BEEB-B99806E4E5D1}"/>
               </a:ext>
             </a:extLst>
@@ -4200,7 +3958,7 @@
 </p:sld>
 </file>
 
-<file path=ppt/slides/slide5.xml><?xml version="1.0" encoding="utf-8"?>
+<file path=ppt/slides/slide4.xml><?xml version="1.0" encoding="utf-8"?>
 <p:sld xmlns:a="http://schemas.openxmlformats.org/drawingml/2006/main" xmlns:r="http://schemas.openxmlformats.org/officeDocument/2006/relationships" xmlns:p="http://schemas.openxmlformats.org/presentationml/2006/main">
   <p:cSld>
     <p:spTree>
@@ -4290,6 +4048,137 @@
 </p:sld>
 </file>
 
+<file path=ppt/slides/slide5.xml><?xml version="1.0" encoding="utf-8"?>
+<p:sld xmlns:a="http://schemas.openxmlformats.org/drawingml/2006/main" xmlns:r="http://schemas.openxmlformats.org/officeDocument/2006/relationships" xmlns:p="http://schemas.openxmlformats.org/presentationml/2006/main">
+  <p:cSld>
+    <p:spTree>
+      <p:nvGrpSpPr>
+        <p:cNvPr id="1" name=""/>
+        <p:cNvGrpSpPr/>
+        <p:nvPr/>
+      </p:nvGrpSpPr>
+      <p:grpSpPr>
+        <a:xfrm>
+          <a:off x="0" y="0"/>
+          <a:ext cx="0" cy="0"/>
+          <a:chOff x="0" y="0"/>
+          <a:chExt cx="0" cy="0"/>
+        </a:xfrm>
+      </p:grpSpPr>
+      <p:sp>
+        <p:nvSpPr>
+          <p:cNvPr id="2" name="Title 1">
+            <a:extLst>
+              <a:ext uri="{FF2B5EF4-FFF2-40B4-BE49-F238E27FC236}">
+                <a16:creationId xmlns:a16="http://schemas.microsoft.com/office/drawing/2014/main" id="{B45F8EFE-A045-80AE-0201-6C06CEA6F37E}"/>
+              </a:ext>
+            </a:extLst>
+          </p:cNvPr>
+          <p:cNvSpPr>
+            <a:spLocks noGrp="1"/>
+          </p:cNvSpPr>
+          <p:nvPr>
+            <p:ph type="title"/>
+          </p:nvPr>
+        </p:nvSpPr>
+        <p:spPr/>
+        <p:txBody>
+          <a:bodyPr/>
+          <a:lstStyle/>
+          <a:p>
+            <a:r>
+              <a:rPr lang="en-US" dirty="0"/>
+              <a:t>Open Source vs Closed Source</a:t>
+            </a:r>
+          </a:p>
+        </p:txBody>
+      </p:sp>
+      <p:sp>
+        <p:nvSpPr>
+          <p:cNvPr id="3" name="Content Placeholder 2">
+            <a:extLst>
+              <a:ext uri="{FF2B5EF4-FFF2-40B4-BE49-F238E27FC236}">
+                <a16:creationId xmlns:a16="http://schemas.microsoft.com/office/drawing/2014/main" id="{C5C9A071-16F7-11CD-F1B3-9B5F67420A5F}"/>
+              </a:ext>
+            </a:extLst>
+          </p:cNvPr>
+          <p:cNvSpPr>
+            <a:spLocks noGrp="1"/>
+          </p:cNvSpPr>
+          <p:nvPr>
+            <p:ph idx="1"/>
+          </p:nvPr>
+        </p:nvSpPr>
+        <p:spPr/>
+        <p:txBody>
+          <a:bodyPr/>
+          <a:lstStyle/>
+          <a:p>
+            <a:pPr marL="0" indent="0">
+              <a:buNone/>
+            </a:pPr>
+            <a:r>
+              <a:rPr lang="en-US" dirty="0"/>
+              <a:t>Or: Text-Fabric vs Accordance</a:t>
+            </a:r>
+          </a:p>
+          <a:p>
+            <a:endParaRPr lang="en-US" dirty="0"/>
+          </a:p>
+          <a:p>
+            <a:pPr marL="0" indent="0">
+              <a:buNone/>
+            </a:pPr>
+            <a:r>
+              <a:rPr lang="en-US" dirty="0"/>
+              <a:t>Pros of open source</a:t>
+            </a:r>
+          </a:p>
+          <a:p>
+            <a:pPr marL="0" indent="0">
+              <a:buNone/>
+            </a:pPr>
+            <a:r>
+              <a:rPr lang="en-US" dirty="0"/>
+              <a:t>Free, community-driven innovation, customizable.</a:t>
+            </a:r>
+          </a:p>
+          <a:p>
+            <a:endParaRPr lang="en-US" dirty="0"/>
+          </a:p>
+          <a:p>
+            <a:pPr marL="0" indent="0">
+              <a:buNone/>
+            </a:pPr>
+            <a:r>
+              <a:rPr lang="en-US" dirty="0"/>
+              <a:t>Pros of closed source</a:t>
+            </a:r>
+          </a:p>
+          <a:p>
+            <a:pPr marL="0" indent="0">
+              <a:buNone/>
+            </a:pPr>
+            <a:r>
+              <a:rPr lang="en-US" dirty="0"/>
+              <a:t>User-friendly interfaces, high stability, and easy to install/use.</a:t>
+            </a:r>
+          </a:p>
+        </p:txBody>
+      </p:sp>
+    </p:spTree>
+    <p:extLst>
+      <p:ext uri="{BB962C8B-B14F-4D97-AF65-F5344CB8AC3E}">
+        <p14:creationId xmlns:p14="http://schemas.microsoft.com/office/powerpoint/2010/main" val="1292225054"/>
+      </p:ext>
+    </p:extLst>
+  </p:cSld>
+  <p:clrMapOvr>
+    <a:masterClrMapping/>
+  </p:clrMapOvr>
+</p:sld>
+</file>
+
 <file path=ppt/slides/slide6.xml><?xml version="1.0" encoding="utf-8"?>
 <p:sld xmlns:a="http://schemas.openxmlformats.org/drawingml/2006/main" xmlns:r="http://schemas.openxmlformats.org/officeDocument/2006/relationships" xmlns:p="http://schemas.openxmlformats.org/presentationml/2006/main">
   <p:cSld>
@@ -4312,7 +4201,7 @@
           <p:cNvPr id="2" name="Title 1">
             <a:extLst>
               <a:ext uri="{FF2B5EF4-FFF2-40B4-BE49-F238E27FC236}">
-                <a16:creationId xmlns:a16="http://schemas.microsoft.com/office/drawing/2014/main" id="{B45F8EFE-A045-80AE-0201-6C06CEA6F37E}"/>
+                <a16:creationId xmlns:a16="http://schemas.microsoft.com/office/drawing/2014/main" id="{D8160AFD-C5AC-9F8B-62AB-BE6A71EF96DE}"/>
               </a:ext>
             </a:extLst>
           </p:cNvPr>
@@ -4340,7 +4229,7 @@
           <p:cNvPr id="3" name="Content Placeholder 2">
             <a:extLst>
               <a:ext uri="{FF2B5EF4-FFF2-40B4-BE49-F238E27FC236}">
-                <a16:creationId xmlns:a16="http://schemas.microsoft.com/office/drawing/2014/main" id="{C5C9A071-16F7-11CD-F1B3-9B5F67420A5F}"/>
+                <a16:creationId xmlns:a16="http://schemas.microsoft.com/office/drawing/2014/main" id="{C1928EC3-D46A-0230-049F-F9FE64C5B8A7}"/>
               </a:ext>
             </a:extLst>
           </p:cNvPr>
@@ -4361,10 +4250,22 @@
             </a:pPr>
             <a:r>
               <a:rPr lang="en-US" dirty="0"/>
-              <a:t>Or: Text-Fabric vs Accordance</a:t>
-            </a:r>
-          </a:p>
-          <a:p>
+              <a:t>Cons of Open Source</a:t>
+            </a:r>
+          </a:p>
+          <a:p>
+            <a:pPr marL="0" indent="0">
+              <a:buNone/>
+            </a:pPr>
+            <a:r>
+              <a:rPr lang="en-US" dirty="0"/>
+              <a:t>Requires technical skills, lacks official, guaranteed support, and documentation can be sparse.</a:t>
+            </a:r>
+          </a:p>
+          <a:p>
+            <a:pPr marL="0" indent="0">
+              <a:buNone/>
+            </a:pPr>
             <a:endParaRPr lang="en-US" dirty="0"/>
           </a:p>
           <a:p>
@@ -4373,7 +4274,7 @@
             </a:pPr>
             <a:r>
               <a:rPr lang="en-US" dirty="0"/>
-              <a:t>Pros of open source</a:t>
+              <a:t>Cons of Closed Source</a:t>
             </a:r>
           </a:p>
           <a:p>
@@ -4382,36 +4283,21 @@
             </a:pPr>
             <a:r>
               <a:rPr lang="en-US" dirty="0"/>
-              <a:t>Free, community-driven innovation, customizable.</a:t>
-            </a:r>
-          </a:p>
-          <a:p>
+              <a:t>Expensive licensing, limited customization, dependence on vendor for updates, and less transparency.</a:t>
+            </a:r>
+          </a:p>
+          <a:p>
+            <a:pPr marL="0" indent="0">
+              <a:buNone/>
+            </a:pPr>
             <a:endParaRPr lang="en-US" dirty="0"/>
-          </a:p>
-          <a:p>
-            <a:pPr marL="0" indent="0">
-              <a:buNone/>
-            </a:pPr>
-            <a:r>
-              <a:rPr lang="en-US" dirty="0"/>
-              <a:t>Pros of closed source</a:t>
-            </a:r>
-          </a:p>
-          <a:p>
-            <a:pPr marL="0" indent="0">
-              <a:buNone/>
-            </a:pPr>
-            <a:r>
-              <a:rPr lang="en-US" dirty="0"/>
-              <a:t>User-friendly interfaces, high stability, and easy to install/use.</a:t>
-            </a:r>
           </a:p>
         </p:txBody>
       </p:sp>
     </p:spTree>
     <p:extLst>
       <p:ext uri="{BB962C8B-B14F-4D97-AF65-F5344CB8AC3E}">
-        <p14:creationId xmlns:p14="http://schemas.microsoft.com/office/powerpoint/2010/main" val="1292225054"/>
+        <p14:creationId xmlns:p14="http://schemas.microsoft.com/office/powerpoint/2010/main" val="1977256338"/>
       </p:ext>
     </p:extLst>
   </p:cSld>
@@ -4443,7 +4329,7 @@
           <p:cNvPr id="2" name="Title 1">
             <a:extLst>
               <a:ext uri="{FF2B5EF4-FFF2-40B4-BE49-F238E27FC236}">
-                <a16:creationId xmlns:a16="http://schemas.microsoft.com/office/drawing/2014/main" id="{D8160AFD-C5AC-9F8B-62AB-BE6A71EF96DE}"/>
+                <a16:creationId xmlns:a16="http://schemas.microsoft.com/office/drawing/2014/main" id="{85C061F4-F631-F1A3-F1D3-8F74E53ED99C}"/>
               </a:ext>
             </a:extLst>
           </p:cNvPr>
@@ -4461,7 +4347,7 @@
           <a:p>
             <a:r>
               <a:rPr lang="en-US" dirty="0"/>
-              <a:t>Open Source vs Closed Source</a:t>
+              <a:t>Open Source vs Closed Source: my opinion</a:t>
             </a:r>
           </a:p>
         </p:txBody>
@@ -4471,7 +4357,7 @@
           <p:cNvPr id="3" name="Content Placeholder 2">
             <a:extLst>
               <a:ext uri="{FF2B5EF4-FFF2-40B4-BE49-F238E27FC236}">
-                <a16:creationId xmlns:a16="http://schemas.microsoft.com/office/drawing/2014/main" id="{C1928EC3-D46A-0230-049F-F9FE64C5B8A7}"/>
+                <a16:creationId xmlns:a16="http://schemas.microsoft.com/office/drawing/2014/main" id="{1DA3BF38-B024-B118-CFDF-BE9193E0D8C4}"/>
               </a:ext>
             </a:extLst>
           </p:cNvPr>
@@ -4487,12 +4373,18 @@
           <a:bodyPr/>
           <a:lstStyle/>
           <a:p>
+            <a:r>
+              <a:rPr lang="en-US" dirty="0"/>
+              <a:t>Text Fabric is more flexible and transparent than Accordance:</a:t>
+            </a:r>
+          </a:p>
+          <a:p>
             <a:pPr marL="0" indent="0">
               <a:buNone/>
             </a:pPr>
             <a:r>
               <a:rPr lang="en-US" dirty="0"/>
-              <a:t>Cons of Open Source</a:t>
+              <a:t>-write queries with Python.</a:t>
             </a:r>
           </a:p>
           <a:p>
@@ -4501,7 +4393,16 @@
             </a:pPr>
             <a:r>
               <a:rPr lang="en-US" dirty="0"/>
-              <a:t>Requires technical skills, lacks official, guaranteed support, and documentation can be sparse.</a:t>
+              <a:t>-export query results.</a:t>
+            </a:r>
+          </a:p>
+          <a:p>
+            <a:pPr marL="0" indent="0">
+              <a:buNone/>
+            </a:pPr>
+            <a:r>
+              <a:rPr lang="en-US" dirty="0"/>
+              <a:t>-integration with other datasets (e.g. DSS, SP).</a:t>
             </a:r>
           </a:p>
           <a:p>
@@ -4516,30 +4417,15 @@
             </a:pPr>
             <a:r>
               <a:rPr lang="en-US" dirty="0"/>
-              <a:t>Cons of Closed Source</a:t>
-            </a:r>
-          </a:p>
-          <a:p>
-            <a:pPr marL="0" indent="0">
-              <a:buNone/>
-            </a:pPr>
-            <a:r>
-              <a:rPr lang="en-US" dirty="0"/>
-              <a:t>Expensive licensing, limited customization, dependence on vendor for updates, and less transparency.</a:t>
-            </a:r>
-          </a:p>
-          <a:p>
-            <a:pPr marL="0" indent="0">
-              <a:buNone/>
-            </a:pPr>
-            <a:endParaRPr lang="en-US" dirty="0"/>
+              <a:t>-&gt; It is better suited as a research tool.</a:t>
+            </a:r>
           </a:p>
         </p:txBody>
       </p:sp>
     </p:spTree>
     <p:extLst>
       <p:ext uri="{BB962C8B-B14F-4D97-AF65-F5344CB8AC3E}">
-        <p14:creationId xmlns:p14="http://schemas.microsoft.com/office/powerpoint/2010/main" val="1977256338"/>
+        <p14:creationId xmlns:p14="http://schemas.microsoft.com/office/powerpoint/2010/main" val="116765940"/>
       </p:ext>
     </p:extLst>
   </p:cSld>
@@ -4571,7 +4457,7 @@
           <p:cNvPr id="2" name="Title 1">
             <a:extLst>
               <a:ext uri="{FF2B5EF4-FFF2-40B4-BE49-F238E27FC236}">
-                <a16:creationId xmlns:a16="http://schemas.microsoft.com/office/drawing/2014/main" id="{85C061F4-F631-F1A3-F1D3-8F74E53ED99C}"/>
+                <a16:creationId xmlns:a16="http://schemas.microsoft.com/office/drawing/2014/main" id="{0FC6F630-E6E0-4AC6-51E5-FD6E329C2CB8}"/>
               </a:ext>
             </a:extLst>
           </p:cNvPr>
@@ -4589,7 +4475,7 @@
           <a:p>
             <a:r>
               <a:rPr lang="en-US" dirty="0"/>
-              <a:t>Open Source vs Closed Source: my opinion</a:t>
+              <a:t>Queries</a:t>
             </a:r>
           </a:p>
         </p:txBody>
@@ -4599,7 +4485,7 @@
           <p:cNvPr id="3" name="Content Placeholder 2">
             <a:extLst>
               <a:ext uri="{FF2B5EF4-FFF2-40B4-BE49-F238E27FC236}">
-                <a16:creationId xmlns:a16="http://schemas.microsoft.com/office/drawing/2014/main" id="{1DA3BF38-B024-B118-CFDF-BE9193E0D8C4}"/>
+                <a16:creationId xmlns:a16="http://schemas.microsoft.com/office/drawing/2014/main" id="{D9C94CD4-7691-12E7-48B7-0EEF24706D5F}"/>
               </a:ext>
             </a:extLst>
           </p:cNvPr>
@@ -4612,39 +4498,33 @@
         </p:nvSpPr>
         <p:spPr/>
         <p:txBody>
-          <a:bodyPr/>
-          <a:lstStyle/>
-          <a:p>
-            <a:r>
-              <a:rPr lang="en-US" dirty="0"/>
-              <a:t>Text Fabric is more flexible than Accordance:</a:t>
-            </a:r>
-          </a:p>
+          <a:bodyPr>
+            <a:normAutofit fontScale="92500" lnSpcReduction="20000"/>
+          </a:bodyPr>
+          <a:lstStyle/>
           <a:p>
             <a:pPr marL="0" indent="0">
               <a:buNone/>
             </a:pPr>
             <a:r>
               <a:rPr lang="en-US" dirty="0"/>
-              <a:t>-write queries with Python.</a:t>
-            </a:r>
+              <a:t>A query has a template structure:</a:t>
+            </a:r>
+          </a:p>
+          <a:p>
+            <a:endParaRPr lang="en-US" dirty="0"/>
           </a:p>
           <a:p>
             <a:pPr marL="0" indent="0">
               <a:buNone/>
             </a:pPr>
             <a:r>
-              <a:rPr lang="en-US" dirty="0"/>
-              <a:t>-export query results.</a:t>
-            </a:r>
-          </a:p>
-          <a:p>
-            <a:pPr marL="0" indent="0">
-              <a:buNone/>
-            </a:pPr>
-            <a:r>
-              <a:rPr lang="en-US" dirty="0"/>
-              <a:t>-integration with other datasets (e.g. DSS, SP).</a:t>
+              <a:rPr lang="en-US" dirty="0">
+                <a:highlight>
+                  <a:srgbClr val="FFFF00"/>
+                </a:highlight>
+              </a:rPr>
+              <a:t>object-type feature=value</a:t>
             </a:r>
           </a:p>
           <a:p>
@@ -4657,9 +4537,53 @@
             <a:pPr marL="0" indent="0">
               <a:buNone/>
             </a:pPr>
-            <a:r>
-              <a:rPr lang="en-US" dirty="0"/>
-              <a:t>-&gt; It is better suited as a research tool.</a:t>
+            <a:endParaRPr lang="en-US" dirty="0"/>
+          </a:p>
+          <a:p>
+            <a:pPr marL="0" indent="0">
+              <a:buNone/>
+            </a:pPr>
+            <a:r>
+              <a:rPr lang="en-US" dirty="0"/>
+              <a:t>Examples:</a:t>
+            </a:r>
+          </a:p>
+          <a:p>
+            <a:pPr marL="0" indent="0">
+              <a:buNone/>
+            </a:pPr>
+            <a:endParaRPr lang="en-US" dirty="0"/>
+          </a:p>
+          <a:p>
+            <a:pPr marL="0" indent="0">
+              <a:buNone/>
+            </a:pPr>
+            <a:r>
+              <a:rPr lang="en-US" dirty="0">
+                <a:highlight>
+                  <a:srgbClr val="FFFF00"/>
+                </a:highlight>
+              </a:rPr>
+              <a:t>word nu=pl</a:t>
+            </a:r>
+          </a:p>
+          <a:p>
+            <a:pPr marL="0" indent="0">
+              <a:buNone/>
+            </a:pPr>
+            <a:endParaRPr lang="en-US" dirty="0"/>
+          </a:p>
+          <a:p>
+            <a:pPr marL="0" indent="0">
+              <a:buNone/>
+            </a:pPr>
+            <a:r>
+              <a:rPr lang="en-US" dirty="0">
+                <a:highlight>
+                  <a:srgbClr val="FFFF00"/>
+                </a:highlight>
+              </a:rPr>
+              <a:t>phrase function=Subj</a:t>
             </a:r>
           </a:p>
         </p:txBody>
@@ -4667,7 +4591,7 @@
     </p:spTree>
     <p:extLst>
       <p:ext uri="{BB962C8B-B14F-4D97-AF65-F5344CB8AC3E}">
-        <p14:creationId xmlns:p14="http://schemas.microsoft.com/office/powerpoint/2010/main" val="116765940"/>
+        <p14:creationId xmlns:p14="http://schemas.microsoft.com/office/powerpoint/2010/main" val="3237721129"/>
       </p:ext>
     </p:extLst>
   </p:cSld>

</xml_diff>

<commit_message>
small changes in pptx
</commit_message>
<xml_diff>
--- a/presentation_6_march_2026.pptx
+++ b/presentation_6_march_2026.pptx
@@ -269,7 +269,7 @@
           <a:p>
             <a:fld id="{84A31011-0B8E-40B0-B333-E081CF3EF4C8}" type="datetimeFigureOut">
               <a:rPr lang="en-US" smtClean="0"/>
-              <a:t>3/5/2026</a:t>
+              <a:t>3/6/2026</a:t>
             </a:fld>
             <a:endParaRPr lang="en-US"/>
           </a:p>
@@ -467,7 +467,7 @@
           <a:p>
             <a:fld id="{84A31011-0B8E-40B0-B333-E081CF3EF4C8}" type="datetimeFigureOut">
               <a:rPr lang="en-US" smtClean="0"/>
-              <a:t>3/5/2026</a:t>
+              <a:t>3/6/2026</a:t>
             </a:fld>
             <a:endParaRPr lang="en-US"/>
           </a:p>
@@ -675,7 +675,7 @@
           <a:p>
             <a:fld id="{84A31011-0B8E-40B0-B333-E081CF3EF4C8}" type="datetimeFigureOut">
               <a:rPr lang="en-US" smtClean="0"/>
-              <a:t>3/5/2026</a:t>
+              <a:t>3/6/2026</a:t>
             </a:fld>
             <a:endParaRPr lang="en-US"/>
           </a:p>
@@ -873,7 +873,7 @@
           <a:p>
             <a:fld id="{84A31011-0B8E-40B0-B333-E081CF3EF4C8}" type="datetimeFigureOut">
               <a:rPr lang="en-US" smtClean="0"/>
-              <a:t>3/5/2026</a:t>
+              <a:t>3/6/2026</a:t>
             </a:fld>
             <a:endParaRPr lang="en-US"/>
           </a:p>
@@ -1148,7 +1148,7 @@
           <a:p>
             <a:fld id="{84A31011-0B8E-40B0-B333-E081CF3EF4C8}" type="datetimeFigureOut">
               <a:rPr lang="en-US" smtClean="0"/>
-              <a:t>3/5/2026</a:t>
+              <a:t>3/6/2026</a:t>
             </a:fld>
             <a:endParaRPr lang="en-US"/>
           </a:p>
@@ -1413,7 +1413,7 @@
           <a:p>
             <a:fld id="{84A31011-0B8E-40B0-B333-E081CF3EF4C8}" type="datetimeFigureOut">
               <a:rPr lang="en-US" smtClean="0"/>
-              <a:t>3/5/2026</a:t>
+              <a:t>3/6/2026</a:t>
             </a:fld>
             <a:endParaRPr lang="en-US"/>
           </a:p>
@@ -1825,7 +1825,7 @@
           <a:p>
             <a:fld id="{84A31011-0B8E-40B0-B333-E081CF3EF4C8}" type="datetimeFigureOut">
               <a:rPr lang="en-US" smtClean="0"/>
-              <a:t>3/5/2026</a:t>
+              <a:t>3/6/2026</a:t>
             </a:fld>
             <a:endParaRPr lang="en-US"/>
           </a:p>
@@ -1966,7 +1966,7 @@
           <a:p>
             <a:fld id="{84A31011-0B8E-40B0-B333-E081CF3EF4C8}" type="datetimeFigureOut">
               <a:rPr lang="en-US" smtClean="0"/>
-              <a:t>3/5/2026</a:t>
+              <a:t>3/6/2026</a:t>
             </a:fld>
             <a:endParaRPr lang="en-US"/>
           </a:p>
@@ -2079,7 +2079,7 @@
           <a:p>
             <a:fld id="{84A31011-0B8E-40B0-B333-E081CF3EF4C8}" type="datetimeFigureOut">
               <a:rPr lang="en-US" smtClean="0"/>
-              <a:t>3/5/2026</a:t>
+              <a:t>3/6/2026</a:t>
             </a:fld>
             <a:endParaRPr lang="en-US"/>
           </a:p>
@@ -2390,7 +2390,7 @@
           <a:p>
             <a:fld id="{84A31011-0B8E-40B0-B333-E081CF3EF4C8}" type="datetimeFigureOut">
               <a:rPr lang="en-US" smtClean="0"/>
-              <a:t>3/5/2026</a:t>
+              <a:t>3/6/2026</a:t>
             </a:fld>
             <a:endParaRPr lang="en-US"/>
           </a:p>
@@ -2678,7 +2678,7 @@
           <a:p>
             <a:fld id="{84A31011-0B8E-40B0-B333-E081CF3EF4C8}" type="datetimeFigureOut">
               <a:rPr lang="en-US" smtClean="0"/>
-              <a:t>3/5/2026</a:t>
+              <a:t>3/6/2026</a:t>
             </a:fld>
             <a:endParaRPr lang="en-US"/>
           </a:p>
@@ -2919,7 +2919,7 @@
           <a:p>
             <a:fld id="{84A31011-0B8E-40B0-B333-E081CF3EF4C8}" type="datetimeFigureOut">
               <a:rPr lang="en-US" smtClean="0"/>
-              <a:t>3/5/2026</a:t>
+              <a:t>3/6/2026</a:t>
             </a:fld>
             <a:endParaRPr lang="en-US"/>
           </a:p>
@@ -3796,13 +3796,19 @@
             </a:r>
             <a:r>
               <a:rPr lang="en-US" dirty="0"/>
-              <a:t>(BHSA).</a:t>
+              <a:t>(BHSA = ETCBC dataset of the MT).</a:t>
             </a:r>
           </a:p>
           <a:p>
             <a:r>
               <a:rPr lang="en-US" dirty="0"/>
               <a:t>Analyze the results.</a:t>
+            </a:r>
+          </a:p>
+          <a:p>
+            <a:r>
+              <a:rPr lang="en-US" dirty="0"/>
+              <a:t>Software: Text-Fabric. Python package for processing texts with annotations.</a:t>
             </a:r>
           </a:p>
         </p:txBody>
@@ -3920,7 +3926,7 @@
             </a:r>
             <a:r>
               <a:rPr lang="en-US" dirty="0"/>
-              <a:t> Notebook.</a:t>
+              <a:t> Notebook, other datasets.</a:t>
             </a:r>
           </a:p>
           <a:p>
@@ -4373,6 +4379,9 @@
           <a:bodyPr/>
           <a:lstStyle/>
           <a:p>
+            <a:pPr marL="0" indent="0">
+              <a:buNone/>
+            </a:pPr>
             <a:r>
               <a:rPr lang="en-US" dirty="0"/>
               <a:t>Text Fabric is more flexible and transparent than Accordance:</a:t>
@@ -4384,7 +4393,7 @@
             </a:pPr>
             <a:r>
               <a:rPr lang="en-US" dirty="0"/>
-              <a:t>-write queries with Python.</a:t>
+              <a:t>-integration with Python scripts.</a:t>
             </a:r>
           </a:p>
           <a:p>
@@ -4410,6 +4419,15 @@
               <a:buNone/>
             </a:pPr>
             <a:endParaRPr lang="en-US" dirty="0"/>
+          </a:p>
+          <a:p>
+            <a:pPr marL="0" indent="0">
+              <a:buNone/>
+            </a:pPr>
+            <a:r>
+              <a:rPr lang="en-US" dirty="0"/>
+              <a:t>-&gt; Reproducible and controllable.</a:t>
+            </a:r>
           </a:p>
           <a:p>
             <a:pPr marL="0" indent="0">
@@ -4499,7 +4517,7 @@
         <p:spPr/>
         <p:txBody>
           <a:bodyPr>
-            <a:normAutofit fontScale="92500" lnSpcReduction="20000"/>
+            <a:normAutofit fontScale="85000" lnSpcReduction="20000"/>
           </a:bodyPr>
           <a:lstStyle/>
           <a:p>
@@ -4507,8 +4525,18 @@
               <a:buNone/>
             </a:pPr>
             <a:r>
-              <a:rPr lang="en-US" dirty="0"/>
-              <a:t>A query has a template structure:</a:t>
+              <a:rPr lang="en-US"/>
+              <a:t>Query language: “Search”.</a:t>
+            </a:r>
+            <a:endParaRPr lang="en-US" dirty="0"/>
+          </a:p>
+          <a:p>
+            <a:pPr marL="0" indent="0">
+              <a:buNone/>
+            </a:pPr>
+            <a:r>
+              <a:rPr lang="en-US" dirty="0"/>
+              <a:t>A Search query has a template structure:</a:t>
             </a:r>
           </a:p>
           <a:p>

</xml_diff>